<commit_message>
deck S4: bullets consistent with sensitivity grid
</commit_message>
<xml_diff>
--- a/deliverables/Helix_Optics_Market_Entry_Deck.pptx
+++ b/deliverables/Helix_Optics_Market_Entry_Deck.pptx
@@ -4601,7 +4601,7 @@
                 </a:solidFill>
                 <a:latin typeface="Arial"/>
               </a:rPr>
-              <a:t>Ramp is the sensitive input.</a:t>
+              <a:t>Ramp alone can sink it.</a:t>
             </a:r>
             <a:r>
               <a:rPr sz="1250">
@@ -4610,7 +4610,7 @@
                 </a:solidFill>
                 <a:latin typeface="Arial"/>
               </a:rPr>
-              <a:t> At half the benchmark ramp the trough falls to ≈€0.2M — survival, with nothing spare.</a:t>
+              <a:t> At half the benchmark ramp the trough grazes €0 (−€0.0M) — the case fails with no other help.</a:t>
             </a:r>
           </a:p>
           <a:p>
@@ -4635,7 +4635,7 @@
                 </a:solidFill>
                 <a:latin typeface="Arial"/>
               </a:rPr>
-              <a:t>Delay is the killer when combined.</a:t>
+              <a:t>Delay alone breaks it too.</a:t>
             </a:r>
             <a:r>
               <a:rPr sz="1250">
@@ -4644,7 +4644,7 @@
                 </a:solidFill>
                 <a:latin typeface="Arial"/>
               </a:rPr>
-              <a:t> Half-ramp AND a 24-month delay → trough −€2.1M: insolvent. Either alone is survivable; both together are not.</a:t>
+              <a:t> Any slip past month 12 → trough −€0.8M on the base ramp (the annual model rounds delays up to whole years — deliberately conservative).</a:t>
             </a:r>
           </a:p>
           <a:p>
@@ -4669,7 +4669,7 @@
                 </a:solidFill>
                 <a:latin typeface="Arial"/>
               </a:rPr>
-              <a:t>Price is the cushion.</a:t>
+              <a:t>Together, decisively fatal.</a:t>
             </a:r>
             <a:r>
               <a:rPr sz="1250">
@@ -4678,7 +4678,7 @@
                 </a:solidFill>
                 <a:latin typeface="Arial"/>
               </a:rPr>
-              <a:t> Every €10 of price ≈ €0.2–0.3M of annual EBITDA at scale — procurement discount headroom exists.</a:t>
+              <a:t> Half-ramp AND a 24-month delay → trough −€2.1M.</a:t>
             </a:r>
           </a:p>
           <a:p>
@@ -4703,7 +4703,7 @@
                 </a:solidFill>
                 <a:latin typeface="Arial"/>
               </a:rPr>
-              <a:t>Kill condition, stated up front.</a:t>
+              <a:t>Price is the cushion; month 15 is the tripwire.</a:t>
             </a:r>
             <a:r>
               <a:rPr sz="1250">
@@ -4712,7 +4712,7 @@
                 </a:solidFill>
                 <a:latin typeface="Arial"/>
               </a:rPr>
-              <a:t> If reimbursement hasn't landed by month 18, cut in-market spend and bridge — do not ride the base plan into the trough.</a:t>
+              <a:t> Every €10 of price ≈ €0.2–0.3M of annual EBITDA at scale. No reimbursement signal by month 15 → cut in-market spend and bridge before the trough.</a:t>
             </a:r>
           </a:p>
         </p:txBody>
@@ -5268,7 +5268,7 @@
                 </a:solidFill>
                 <a:latin typeface="Arial"/>
               </a:rPr>
-              <a:t>Break-even moves Y3 → Y4 at ×75% ramp; beyond Y5 only in the red scenarios.</a:t>
+              <a:t>Grid computed by the same engine as the Excel; delays round up to whole years (conservative).</a:t>
             </a:r>
           </a:p>
         </p:txBody>

</xml_diff>

<commit_message>
design audit: de-AI copy sweep, desk tagline, light serif, pipeline rail
</commit_message>
<xml_diff>
--- a/deliverables/Helix_Optics_Market_Entry_Deck.pptx
+++ b/deliverables/Helix_Optics_Market_Entry_Deck.pptx
@@ -3259,7 +3259,7 @@
                 </a:solidFill>
                 <a:latin typeface="Arial"/>
               </a:rPr>
-              <a:t>company EBITDA positive in year 3 — second year of reimbursed sales</a:t>
+              <a:t>company EBITDA positive in year 3, the second year of reimbursed sales</a:t>
             </a:r>
           </a:p>
         </p:txBody>
@@ -3333,7 +3333,7 @@
                 </a:solidFill>
                 <a:latin typeface="Arial"/>
               </a:rPr>
-              <a:t>cash trough — the runway is never exhausted</a:t>
+              <a:t>cash trough: the runway is never exhausted</a:t>
             </a:r>
           </a:p>
         </p:txBody>
@@ -3407,7 +3407,7 @@
                 </a:solidFill>
                 <a:latin typeface="Arial"/>
               </a:rPr>
-              <a:t>addressable FIT-positives — 92% of Germany's volume, none of its barriers</a:t>
+              <a:t>addressable FIT-positives: 92% of Germany's volume, none of its barriers</a:t>
             </a:r>
           </a:p>
         </p:txBody>
@@ -3481,7 +3481,7 @@
                 </a:solidFill>
                 <a:latin typeface="Arial"/>
               </a:rPr>
-              <a:t>per 100 patients triaged, at €650/colonoscopy — the payer wants this</a:t>
+              <a:t>per 100 patients triaged, at €650 per avoided colonoscopy. The payer wants this</a:t>
             </a:r>
           </a:p>
         </p:txBody>
@@ -3544,7 +3544,7 @@
                 </a:solidFill>
                 <a:latin typeface="Arial"/>
               </a:rPr>
-              <a:t>The Netherlands is the only market of the four that survives on the €4.0M runway — 12 months to reimbursement, one national procurement route, no incumbent.</a:t>
+              <a:t>The Netherlands is the only market of the four that survives on the €4.0M runway: 12 months to reimbursement, one national procurement route, no incumbent.</a:t>
             </a:r>
           </a:p>
         </p:txBody>
@@ -3756,7 +3756,7 @@
                 </a:solidFill>
                 <a:latin typeface="Arial"/>
               </a:rPr>
-              <a:t> The pathway is procedural — and the national report is explicit that clinical investigators, lab partnerships and prior studies do NOT shorten it.</a:t>
+              <a:t> The pathway is procedural, and the national report is explicit that clinical investigators, lab partnerships and prior studies do NOT shorten it.</a:t>
             </a:r>
           </a:p>
           <a:p>
@@ -3790,7 +3790,7 @@
                 </a:solidFill>
                 <a:latin typeface="Arial"/>
               </a:rPr>
-              <a:t> Selective contracts and self-pay have 'historically covered negligible volume' — planning assumption: immaterial.</a:t>
+              <a:t> Selective contracts and self-pay have 'historically covered negligible volume'. Planning assumption: immaterial.</a:t>
             </a:r>
           </a:p>
           <a:p>
@@ -3824,7 +3824,7 @@
                 </a:solidFill>
                 <a:latin typeface="Arial"/>
               </a:rPr>
-              <a:t> Burn reaches ~€2.85M in year 1; cash bottoms at -1.4M — insolvent before the first reimbursed euro.</a:t>
+              <a:t> Burn reaches ~€2.85M in year 1; cash bottoms at -1.4M, insolvent before the first reimbursed euro.</a:t>
             </a:r>
           </a:p>
           <a:p>
@@ -3892,7 +3892,7 @@
                 </a:solidFill>
                 <a:latin typeface="Arial"/>
               </a:rPr>
-              <a:t> Germany's entire organised addressable volume is 174,240/yr — the company-reported figure is 1.7× the whole market. Pipeline check CHK-02 rejects it; the independent 35–40% share (~61–70k tests) is used instead.</a:t>
+              <a:t> Germany's entire organised addressable volume is 174,240/yr; the company-reported figure is 1.7× the whole market. Pipeline check CHK-02 rejects it, and the independent 35–40% share (~61–70k tests) is used instead.</a:t>
             </a:r>
           </a:p>
         </p:txBody>
@@ -3955,7 +3955,7 @@
                 </a:solidFill>
                 <a:latin typeface="Arial"/>
               </a:rPr>
-              <a:t>Right market later, unaffordable market now: file the German reimbursement application early (the clock is procedural), enter when new capital or NL cash flow can fund the two-year wait.</a:t>
+              <a:t>Right market later, unaffordable market now. File the German application early (the clock is procedural); enter when new capital or NL cash flow can fund the two-year wait.</a:t>
             </a:r>
           </a:p>
         </p:txBody>
@@ -4167,7 +4167,7 @@
                 </a:solidFill>
                 <a:latin typeface="Arial"/>
               </a:rPr>
-              <a:t> 71% participation × 9.1% positivity → 159,910 FIT-positives/yr from a country of 4.95M eligible — 92% of Germany's volume.</a:t>
+              <a:t> 71% participation × 9.1% positivity → 159,910 FIT-positives/yr from 4.95M eligible: 92% of Germany's volume.</a:t>
             </a:r>
           </a:p>
           <a:p>
@@ -4201,7 +4201,7 @@
                 </a:solidFill>
                 <a:latin typeface="Arial"/>
               </a:rPr>
-              <a:t> Centralised programme, one national procurement decision — no region-by-region grind.</a:t>
+              <a:t> Centralised programme, one national procurement decision. No region-by-region grind.</a:t>
             </a:r>
           </a:p>
           <a:p>
@@ -4269,7 +4269,7 @@
                 </a:solidFill>
                 <a:latin typeface="Arial"/>
               </a:rPr>
-              <a:t> Reducing avoidable colonoscopies is an explicit programme priority — register data shows referrals at ~103% of national endoscopy capacity.</a:t>
+              <a:t> Reducing avoidable colonoscopies is an explicit programme priority; register data shows referrals at ~103% of national endoscopy capacity.</a:t>
             </a:r>
           </a:p>
           <a:p>
@@ -4610,7 +4610,7 @@
                 </a:solidFill>
                 <a:latin typeface="Arial"/>
               </a:rPr>
-              <a:t> At half the benchmark ramp the trough grazes €0 (−€0.0M) — the case fails with no other help.</a:t>
+              <a:t> At half the benchmark ramp the trough grazes €0 (−€0.0M): the case fails without help.</a:t>
             </a:r>
           </a:p>
           <a:p>
@@ -4644,7 +4644,7 @@
                 </a:solidFill>
                 <a:latin typeface="Arial"/>
               </a:rPr>
-              <a:t> Any slip past month 12 → trough −€0.8M on the base ramp (the annual model rounds delays up to whole years — deliberately conservative).</a:t>
+              <a:t> Any slip past month 12 puts the trough at −€0.8M on the base ramp (the annual model rounds delays up to whole years, deliberately conservative).</a:t>
             </a:r>
           </a:p>
           <a:p>
@@ -5808,7 +5808,7 @@
                 </a:solidFill>
                 <a:latin typeface="Arial"/>
               </a:rPr>
-              <a:t>Accelerate</a:t>
+              <a:t>Accelerate:</a:t>
             </a:r>
             <a:r>
               <a:rPr sz="1250">
@@ -5842,7 +5842,7 @@
                 </a:solidFill>
                 <a:latin typeface="Arial"/>
               </a:rPr>
-              <a:t>Delay</a:t>
+              <a:t>Delay:</a:t>
             </a:r>
             <a:r>
               <a:rPr sz="1250">
@@ -5876,7 +5876,7 @@
                 </a:solidFill>
                 <a:latin typeface="Arial"/>
               </a:rPr>
-              <a:t>Abandon / pivot</a:t>
+              <a:t>Abandon / pivot:</a:t>
             </a:r>
             <a:r>
               <a:rPr sz="1250">
@@ -5910,7 +5910,7 @@
                 </a:solidFill>
                 <a:latin typeface="Arial"/>
               </a:rPr>
-              <a:t>What we refuse to do</a:t>
+              <a:t>What we refuse to do:</a:t>
             </a:r>
             <a:r>
               <a:rPr sz="1250">
@@ -5919,7 +5919,7 @@
                 </a:solidFill>
                 <a:latin typeface="Arial"/>
               </a:rPr>
-              <a:t> chase Germany's headline volume with a 24-month unfunded gap, or book the funding call as launch money — it is R&amp;D co-financing only.</a:t>
+              <a:t> chase Germany's headline volume with a 24-month unfunded gap, or book the funding call as launch money. It is R&amp;D co-financing only.</a:t>
             </a:r>
           </a:p>
         </p:txBody>
@@ -5958,7 +5958,7 @@
                 </a:solidFill>
                 <a:latin typeface="Arial"/>
               </a:rPr>
-              <a:t>Pipeline run: 74 values extracted deterministically, 0 AI calls, eval 28/28, 0.9s end-to-end — the same assessment re-runs on markets 5–14 by adding a config entry.</a:t>
+              <a:t>Pipeline run: 74 values extracted deterministically, 0 AI calls, eval 28/28, 0.9s end-to-end. The same assessment re-runs on markets 5–14 by adding a config entry.</a:t>
             </a:r>
           </a:p>
         </p:txBody>

</xml_diff>